<commit_message>
refactor: consolidate all application files into app/ and relocate master docs into docs/
</commit_message>
<xml_diff>
--- a/docs/SIH2026 echobraille (refined).pptx
+++ b/docs/SIH2026 echobraille (refined).pptx
@@ -161,6 +161,35 @@
 </p:presentation>
 </file>
 
+<file path=ppt/changesInfos/changesInfo1.xml><?xml version="1.0" encoding="utf-8"?>
+<pc:chgInfo xmlns:a="http://schemas.openxmlformats.org/drawingml/2006/main" xmlns:r="http://schemas.openxmlformats.org/officeDocument/2006/relationships" xmlns:ac="http://schemas.microsoft.com/office/drawing/2013/main/command" xmlns:pc="http://schemas.microsoft.com/office/powerpoint/2013/main/command">
+  <pc:docChgLst>
+    <pc:chgData name="Dhamodharan M" userId="6d106325e6e6158b" providerId="LiveId" clId="{8439A695-7228-4D11-89CC-7AF9D9947549}"/>
+    <pc:docChg chg="undo custSel modSld">
+      <pc:chgData name="Dhamodharan M" userId="6d106325e6e6158b" providerId="LiveId" clId="{8439A695-7228-4D11-89CC-7AF9D9947549}" dt="2026-09-22T10:34:28.480" v="1" actId="1076"/>
+      <pc:docMkLst>
+        <pc:docMk/>
+      </pc:docMkLst>
+      <pc:sldChg chg="modSp mod">
+        <pc:chgData name="Dhamodharan M" userId="6d106325e6e6158b" providerId="LiveId" clId="{8439A695-7228-4D11-89CC-7AF9D9947549}" dt="2026-09-22T10:34:28.480" v="1" actId="1076"/>
+        <pc:sldMkLst>
+          <pc:docMk/>
+          <pc:sldMk cId="3663567350" sldId="297"/>
+        </pc:sldMkLst>
+        <pc:picChg chg="mod">
+          <ac:chgData name="Dhamodharan M" userId="6d106325e6e6158b" providerId="LiveId" clId="{8439A695-7228-4D11-89CC-7AF9D9947549}" dt="2026-09-22T10:34:28.480" v="1" actId="1076"/>
+          <ac:picMkLst>
+            <pc:docMk/>
+            <pc:sldMk cId="3663567350" sldId="297"/>
+            <ac:picMk id="20" creationId="{45527328-F654-7084-A628-6AE13F852A4E}"/>
+          </ac:picMkLst>
+        </pc:picChg>
+      </pc:sldChg>
+    </pc:docChg>
+  </pc:docChgLst>
+</pc:chgInfo>
+</file>
+
 <file path=ppt/notesMasters/notesMaster1.xml><?xml version="1.0" encoding="utf-8"?>
 <p:notesMaster xmlns:a="http://schemas.openxmlformats.org/drawingml/2006/main" xmlns:r="http://schemas.openxmlformats.org/officeDocument/2006/relationships" xmlns:p="http://schemas.openxmlformats.org/presentationml/2006/main">
   <p:cSld>
@@ -261,7 +290,7 @@
             <a:fld id="{C4D5ADD5-2BBC-4A94-8F86-D9013941F742}" type="datetimeFigureOut">
               <a:rPr lang="en-US"/>
               <a:pPr/>
-              <a:t>9/20/2026</a:t>
+              <a:t>9/22/2026</a:t>
             </a:fld>
             <a:endParaRPr lang="en-US"/>
           </a:p>
@@ -1562,7 +1591,7 @@
           <a:p>
             <a:fld id="{E60792E3-D524-454C-8AFD-A91972900BCB}" type="datetime1">
               <a:rPr lang="en-US" smtClean="0"/>
-              <a:t>9/20/2026</a:t>
+              <a:t>9/22/2026</a:t>
             </a:fld>
             <a:endParaRPr lang="en-US"/>
           </a:p>
@@ -1744,7 +1773,7 @@
           <a:p>
             <a:fld id="{053C3A68-6922-42D3-8905-ECC2D82A3469}" type="datetime1">
               <a:rPr lang="en-US" smtClean="0"/>
-              <a:t>9/20/2026</a:t>
+              <a:t>9/22/2026</a:t>
             </a:fld>
             <a:endParaRPr lang="en-US"/>
           </a:p>
@@ -1936,7 +1965,7 @@
           <a:p>
             <a:fld id="{CB69E9F4-7604-4950-A8B2-8ACDEDB1506E}" type="datetime1">
               <a:rPr lang="en-US" smtClean="0"/>
-              <a:t>9/20/2026</a:t>
+              <a:t>9/22/2026</a:t>
             </a:fld>
             <a:endParaRPr lang="en-US"/>
           </a:p>
@@ -2118,7 +2147,7 @@
           <a:p>
             <a:fld id="{708B7524-32A2-4C20-A58C-BC3BAA1042FC}" type="datetime1">
               <a:rPr lang="en-US" smtClean="0"/>
-              <a:t>9/20/2026</a:t>
+              <a:t>9/22/2026</a:t>
             </a:fld>
             <a:endParaRPr lang="en-US"/>
           </a:p>
@@ -2377,7 +2406,7 @@
           <a:p>
             <a:fld id="{1E994447-D6B2-43BB-A877-57F1A267B999}" type="datetime1">
               <a:rPr lang="en-US" smtClean="0"/>
-              <a:t>9/20/2026</a:t>
+              <a:t>9/22/2026</a:t>
             </a:fld>
             <a:endParaRPr lang="en-US"/>
           </a:p>
@@ -2676,7 +2705,7 @@
           <a:p>
             <a:fld id="{68920E16-BD35-483C-AA6B-346FC7E46DEA}" type="datetime1">
               <a:rPr lang="en-US" smtClean="0"/>
-              <a:t>9/20/2026</a:t>
+              <a:t>9/22/2026</a:t>
             </a:fld>
             <a:endParaRPr lang="en-US"/>
           </a:p>
@@ -3109,7 +3138,7 @@
           <a:p>
             <a:fld id="{2FEAC6F8-5103-4FC0-A69E-5C6AE6469DA8}" type="datetime1">
               <a:rPr lang="en-US" smtClean="0"/>
-              <a:t>9/20/2026</a:t>
+              <a:t>9/22/2026</a:t>
             </a:fld>
             <a:endParaRPr lang="en-US"/>
           </a:p>
@@ -3240,7 +3269,7 @@
           <a:p>
             <a:fld id="{C60C6921-0627-4C8F-83D5-0CF936D2FFDD}" type="datetime1">
               <a:rPr lang="en-US" smtClean="0"/>
-              <a:t>9/20/2026</a:t>
+              <a:t>9/22/2026</a:t>
             </a:fld>
             <a:endParaRPr lang="en-US"/>
           </a:p>
@@ -3349,7 +3378,7 @@
           <a:p>
             <a:fld id="{2FF08AD7-8103-40F8-983C-E2BA6BB9CBE0}" type="datetime1">
               <a:rPr lang="en-US" smtClean="0"/>
-              <a:t>9/20/2026</a:t>
+              <a:t>9/22/2026</a:t>
             </a:fld>
             <a:endParaRPr lang="en-US"/>
           </a:p>
@@ -3638,7 +3667,7 @@
           <a:p>
             <a:fld id="{DF8C06B4-9380-4A4D-AF49-A3596E17DAF5}" type="datetime1">
               <a:rPr lang="en-US" smtClean="0"/>
-              <a:t>9/20/2026</a:t>
+              <a:t>9/22/2026</a:t>
             </a:fld>
             <a:endParaRPr lang="en-US"/>
           </a:p>
@@ -3907,7 +3936,7 @@
           <a:p>
             <a:fld id="{EF7FDEF1-C582-4E22-9E77-D68326471F28}" type="datetime1">
               <a:rPr lang="en-US" smtClean="0"/>
-              <a:t>9/20/2026</a:t>
+              <a:t>9/22/2026</a:t>
             </a:fld>
             <a:endParaRPr lang="en-US"/>
           </a:p>
@@ -4150,7 +4179,7 @@
           <a:p>
             <a:fld id="{780A9602-A9A9-453F-AEF1-37B5837E02CD}" type="datetime1">
               <a:rPr lang="en-US" smtClean="0"/>
-              <a:t>9/20/2026</a:t>
+              <a:t>9/22/2026</a:t>
             </a:fld>
             <a:endParaRPr lang="en-US"/>
           </a:p>

</xml_diff>